<commit_message>
Why We Are Here preview: GM statement net profit, all stores (group YTD $82,240,434)
Co-Authored-By: Claude Opus 5.5 <noreply@anthropic.com>
Claude-Session: https://claude.ai/code/session_01Xa4nFVxuQGXmHARGph9WhS
</commit_message>
<xml_diff>
--- a/day2-deck/decks/Why We Are Here - Preview.pptx
+++ b/day2-deck/decks/Why We Are Here - Preview.pptx
@@ -502,7 +502,7 @@
           <a:p>
             <a:r>
               <a:rPr lang="en-US" dirty="0"/>
-              <a:t>Source: Qlik - Profit &amp; Loss, Jan-Sep 2026 vs 2025, same-store (INEOS excluded). Fixed ops = service (Mechanical) + parts (P&amp;A) department profit: department gross less the department's own expenses. Group net = Net Profit Or Loss on the GM statement.PREVIEW (Noah, Oct 24). Group-level view of fixed ops' weight in the dealership's profit, Jan-Sep. Fixed ops department profit $50,449,894 (2025 $45,336,135); group net profit $82,743,115 (2025 $95,664,709). On the P&amp;L, F&amp;I income, other income and store-level costs are not split by department, so 'the rest of the store' is the group net less fixed ops department profit. If the room uses net before bonus and tax instead ($119,985,939), the share is 42%. Body shop (GMC Prescott) department profit is left out of fixed ops, as everywhere in the deck.</a:t>
+              <a:t>Source: Qlik - Profit &amp; Loss, Jan-Sep 2026 vs 2025, all stores (INEOS included, to match the group P&amp;L). Fixed ops = service (Mechanical) + parts (P&amp;A) department profit: department gross less the department's own expenses. Group net = Net Profit Or Loss on the GM statement.PREVIEW (Noah, Oct 24). Group-level view of fixed ops' weight in the dealership's profit, Jan-Sep. Fixed ops department profit $50,194,950 (2025 $45,336,135); group net profit $82,240,434 (2025 $95,664,709). On the P&amp;L, F&amp;I income, other income and store-level costs are not split by department, so 'the rest of the store' is the group net less fixed ops department profit. Group net = Net Profit Or Loss on the GM statement (P&amp;L summary), all stores; INEOS (opened 2026) is in both lines. Body shop (GMC Prescott) department profit is left out of fixed ops, as everywhere in the deck.</a:t>
             </a:r>
             <a:endParaRPr lang="en-US" dirty="0"/>
           </a:p>
@@ -1335,7 +1335,7 @@
                 <a:ea typeface="Inter" pitchFamily="34" charset="-122"/>
                 <a:cs typeface="Inter" pitchFamily="34" charset="-120"/>
               </a:rPr>
-              <a:t>of the group's net profit came from service and parts: $50.45M of $82.74M (47% in 2025).</a:t>
+              <a:t>of the group's net profit came from service and parts: $50.19M of $82.24M (47% in 2025).</a:t>
             </a:r>
             <a:endParaRPr lang="en-US" sz="1400" dirty="0"/>
           </a:p>
@@ -1396,7 +1396,7 @@
                 <a:ea typeface="Inter" pitchFamily="34" charset="-122"/>
                 <a:cs typeface="Inter" pitchFamily="34" charset="-120"/>
               </a:rPr>
-              <a:t>$50.45M</a:t>
+              <a:t>$50.19M</a:t>
             </a:r>
             <a:endParaRPr lang="en-US" sz="3000" dirty="0"/>
           </a:p>
@@ -1435,7 +1435,7 @@
                 <a:ea typeface="Inter" pitchFamily="34" charset="-122"/>
                 <a:cs typeface="Inter" pitchFamily="34" charset="-120"/>
               </a:rPr>
-              <a:t>Fixed ops department profit. New, used, F&amp;I and the rest of the store together: $32.29M.</a:t>
+              <a:t>Fixed ops department profit. New, used, F&amp;I and the rest of the store together: $32.05M.</a:t>
             </a:r>
             <a:endParaRPr lang="en-US" sz="1400" dirty="0"/>
           </a:p>
@@ -1496,7 +1496,7 @@
                 <a:ea typeface="Inter" pitchFamily="34" charset="-122"/>
                 <a:cs typeface="Inter" pitchFamily="34" charset="-120"/>
               </a:rPr>
-              <a:t>+$5,113,759</a:t>
+              <a:t>+$4,858,815</a:t>
             </a:r>
             <a:endParaRPr lang="en-US" sz="3000" dirty="0"/>
           </a:p>
@@ -1535,7 +1535,7 @@
                 <a:ea typeface="Inter" pitchFamily="34" charset="-122"/>
                 <a:cs typeface="Inter" pitchFamily="34" charset="-120"/>
               </a:rPr>
-              <a:t>More fixed ops profit than 2025, while group net profit fell $12.92M.</a:t>
+              <a:t>More fixed ops profit than 2025, while group net profit fell $13.42M.</a:t>
             </a:r>
             <a:endParaRPr lang="en-US" sz="1400" dirty="0"/>
           </a:p>

</xml_diff>